<commit_message>
updating week 1 slides
</commit_message>
<xml_diff>
--- a/week 1/Intro to Data Science — Week 1 What Is Data Science.pptx
+++ b/week 1/Intro to Data Science — Week 1 What Is Data Science.pptx
@@ -11264,11 +11264,10 @@
           </a:bodyPr>
           <a:lstStyle/>
           <a:p>
-            <a:pPr marL="0" indent="0" algn="l">
+            <a:pPr>
               <a:lnSpc>
                 <a:spcPts val="2380"/>
               </a:lnSpc>
-              <a:buNone/>
             </a:pPr>
             <a:r>
               <a:rPr lang="en-US" sz="1700" b="1" dirty="0">
@@ -11279,7 +11278,7 @@
                 <a:ea typeface="Helvetica" pitchFamily="34" charset="-122"/>
                 <a:cs typeface="Helvetica" pitchFamily="34" charset="-120"/>
               </a:rPr>
-              <a:t>At every arrow ask: what could go wrong here?</a:t>
+              <a:t>At every arrow, what could go wrong here?</a:t>
             </a:r>
             <a:endParaRPr lang="en-US" sz="1700" dirty="0"/>
           </a:p>
@@ -11334,6 +11333,1550 @@
   <p:clrMapOvr>
     <a:masterClrMapping/>
   </p:clrMapOvr>
+  <p:timing>
+    <p:tnLst>
+      <p:par>
+        <p:cTn id="1" dur="indefinite" restart="never" nodeType="tmRoot">
+          <p:childTnLst>
+            <p:seq concurrent="1" nextAc="seek">
+              <p:cTn id="2" dur="indefinite" nodeType="mainSeq">
+                <p:childTnLst>
+                  <p:par>
+                    <p:cTn id="3" fill="hold">
+                      <p:stCondLst>
+                        <p:cond delay="indefinite"/>
+                      </p:stCondLst>
+                      <p:childTnLst>
+                        <p:par>
+                          <p:cTn id="4" fill="hold">
+                            <p:stCondLst>
+                              <p:cond delay="0"/>
+                            </p:stCondLst>
+                            <p:childTnLst>
+                              <p:par>
+                                <p:cTn id="5" presetID="16" presetClass="entr" presetSubtype="21" fill="hold" grpId="0" nodeType="clickEffect">
+                                  <p:stCondLst>
+                                    <p:cond delay="0"/>
+                                  </p:stCondLst>
+                                  <p:childTnLst>
+                                    <p:set>
+                                      <p:cBhvr>
+                                        <p:cTn id="6" dur="1" fill="hold">
+                                          <p:stCondLst>
+                                            <p:cond delay="0"/>
+                                          </p:stCondLst>
+                                        </p:cTn>
+                                        <p:tgtEl>
+                                          <p:spTgt spid="5"/>
+                                        </p:tgtEl>
+                                        <p:attrNameLst>
+                                          <p:attrName>style.visibility</p:attrName>
+                                        </p:attrNameLst>
+                                      </p:cBhvr>
+                                      <p:to>
+                                        <p:strVal val="visible"/>
+                                      </p:to>
+                                    </p:set>
+                                    <p:animEffect transition="in" filter="barn(inVertical)">
+                                      <p:cBhvr>
+                                        <p:cTn id="7" dur="500"/>
+                                        <p:tgtEl>
+                                          <p:spTgt spid="5"/>
+                                        </p:tgtEl>
+                                      </p:cBhvr>
+                                    </p:animEffect>
+                                  </p:childTnLst>
+                                </p:cTn>
+                              </p:par>
+                              <p:par>
+                                <p:cTn id="8" presetID="16" presetClass="entr" presetSubtype="21" fill="hold" grpId="0" nodeType="withEffect">
+                                  <p:stCondLst>
+                                    <p:cond delay="0"/>
+                                  </p:stCondLst>
+                                  <p:childTnLst>
+                                    <p:set>
+                                      <p:cBhvr>
+                                        <p:cTn id="9" dur="1" fill="hold">
+                                          <p:stCondLst>
+                                            <p:cond delay="0"/>
+                                          </p:stCondLst>
+                                        </p:cTn>
+                                        <p:tgtEl>
+                                          <p:spTgt spid="4"/>
+                                        </p:tgtEl>
+                                        <p:attrNameLst>
+                                          <p:attrName>style.visibility</p:attrName>
+                                        </p:attrNameLst>
+                                      </p:cBhvr>
+                                      <p:to>
+                                        <p:strVal val="visible"/>
+                                      </p:to>
+                                    </p:set>
+                                    <p:animEffect transition="in" filter="barn(inVertical)">
+                                      <p:cBhvr>
+                                        <p:cTn id="10" dur="500"/>
+                                        <p:tgtEl>
+                                          <p:spTgt spid="4"/>
+                                        </p:tgtEl>
+                                      </p:cBhvr>
+                                    </p:animEffect>
+                                  </p:childTnLst>
+                                </p:cTn>
+                              </p:par>
+                              <p:par>
+                                <p:cTn id="11" presetID="16" presetClass="entr" presetSubtype="21" fill="hold" grpId="0" nodeType="withEffect">
+                                  <p:stCondLst>
+                                    <p:cond delay="0"/>
+                                  </p:stCondLst>
+                                  <p:childTnLst>
+                                    <p:set>
+                                      <p:cBhvr>
+                                        <p:cTn id="12" dur="1" fill="hold">
+                                          <p:stCondLst>
+                                            <p:cond delay="0"/>
+                                          </p:stCondLst>
+                                        </p:cTn>
+                                        <p:tgtEl>
+                                          <p:spTgt spid="3"/>
+                                        </p:tgtEl>
+                                        <p:attrNameLst>
+                                          <p:attrName>style.visibility</p:attrName>
+                                        </p:attrNameLst>
+                                      </p:cBhvr>
+                                      <p:to>
+                                        <p:strVal val="visible"/>
+                                      </p:to>
+                                    </p:set>
+                                    <p:animEffect transition="in" filter="barn(inVertical)">
+                                      <p:cBhvr>
+                                        <p:cTn id="13" dur="500"/>
+                                        <p:tgtEl>
+                                          <p:spTgt spid="3"/>
+                                        </p:tgtEl>
+                                      </p:cBhvr>
+                                    </p:animEffect>
+                                  </p:childTnLst>
+                                </p:cTn>
+                              </p:par>
+                            </p:childTnLst>
+                          </p:cTn>
+                        </p:par>
+                      </p:childTnLst>
+                    </p:cTn>
+                  </p:par>
+                  <p:par>
+                    <p:cTn id="14" fill="hold">
+                      <p:stCondLst>
+                        <p:cond delay="indefinite"/>
+                      </p:stCondLst>
+                      <p:childTnLst>
+                        <p:par>
+                          <p:cTn id="15" fill="hold">
+                            <p:stCondLst>
+                              <p:cond delay="0"/>
+                            </p:stCondLst>
+                            <p:childTnLst>
+                              <p:par>
+                                <p:cTn id="16" presetID="16" presetClass="entr" presetSubtype="21" fill="hold" grpId="0" nodeType="clickEffect">
+                                  <p:stCondLst>
+                                    <p:cond delay="0"/>
+                                  </p:stCondLst>
+                                  <p:childTnLst>
+                                    <p:set>
+                                      <p:cBhvr>
+                                        <p:cTn id="17" dur="1" fill="hold">
+                                          <p:stCondLst>
+                                            <p:cond delay="0"/>
+                                          </p:stCondLst>
+                                        </p:cTn>
+                                        <p:tgtEl>
+                                          <p:spTgt spid="7"/>
+                                        </p:tgtEl>
+                                        <p:attrNameLst>
+                                          <p:attrName>style.visibility</p:attrName>
+                                        </p:attrNameLst>
+                                      </p:cBhvr>
+                                      <p:to>
+                                        <p:strVal val="visible"/>
+                                      </p:to>
+                                    </p:set>
+                                    <p:animEffect transition="in" filter="barn(inVertical)">
+                                      <p:cBhvr>
+                                        <p:cTn id="18" dur="500"/>
+                                        <p:tgtEl>
+                                          <p:spTgt spid="7"/>
+                                        </p:tgtEl>
+                                      </p:cBhvr>
+                                    </p:animEffect>
+                                  </p:childTnLst>
+                                </p:cTn>
+                              </p:par>
+                              <p:par>
+                                <p:cTn id="19" presetID="16" presetClass="entr" presetSubtype="21" fill="hold" grpId="0" nodeType="withEffect">
+                                  <p:stCondLst>
+                                    <p:cond delay="0"/>
+                                  </p:stCondLst>
+                                  <p:childTnLst>
+                                    <p:set>
+                                      <p:cBhvr>
+                                        <p:cTn id="20" dur="1" fill="hold">
+                                          <p:stCondLst>
+                                            <p:cond delay="0"/>
+                                          </p:stCondLst>
+                                        </p:cTn>
+                                        <p:tgtEl>
+                                          <p:spTgt spid="6"/>
+                                        </p:tgtEl>
+                                        <p:attrNameLst>
+                                          <p:attrName>style.visibility</p:attrName>
+                                        </p:attrNameLst>
+                                      </p:cBhvr>
+                                      <p:to>
+                                        <p:strVal val="visible"/>
+                                      </p:to>
+                                    </p:set>
+                                    <p:animEffect transition="in" filter="barn(inVertical)">
+                                      <p:cBhvr>
+                                        <p:cTn id="21" dur="500"/>
+                                        <p:tgtEl>
+                                          <p:spTgt spid="6"/>
+                                        </p:tgtEl>
+                                      </p:cBhvr>
+                                    </p:animEffect>
+                                  </p:childTnLst>
+                                </p:cTn>
+                              </p:par>
+                              <p:par>
+                                <p:cTn id="22" presetID="16" presetClass="entr" presetSubtype="21" fill="hold" grpId="0" nodeType="withEffect">
+                                  <p:stCondLst>
+                                    <p:cond delay="0"/>
+                                  </p:stCondLst>
+                                  <p:childTnLst>
+                                    <p:set>
+                                      <p:cBhvr>
+                                        <p:cTn id="23" dur="1" fill="hold">
+                                          <p:stCondLst>
+                                            <p:cond delay="0"/>
+                                          </p:stCondLst>
+                                        </p:cTn>
+                                        <p:tgtEl>
+                                          <p:spTgt spid="8"/>
+                                        </p:tgtEl>
+                                        <p:attrNameLst>
+                                          <p:attrName>style.visibility</p:attrName>
+                                        </p:attrNameLst>
+                                      </p:cBhvr>
+                                      <p:to>
+                                        <p:strVal val="visible"/>
+                                      </p:to>
+                                    </p:set>
+                                    <p:animEffect transition="in" filter="barn(inVertical)">
+                                      <p:cBhvr>
+                                        <p:cTn id="24" dur="500"/>
+                                        <p:tgtEl>
+                                          <p:spTgt spid="8"/>
+                                        </p:tgtEl>
+                                      </p:cBhvr>
+                                    </p:animEffect>
+                                  </p:childTnLst>
+                                </p:cTn>
+                              </p:par>
+                            </p:childTnLst>
+                          </p:cTn>
+                        </p:par>
+                      </p:childTnLst>
+                    </p:cTn>
+                  </p:par>
+                  <p:par>
+                    <p:cTn id="25" fill="hold">
+                      <p:stCondLst>
+                        <p:cond delay="indefinite"/>
+                      </p:stCondLst>
+                      <p:childTnLst>
+                        <p:par>
+                          <p:cTn id="26" fill="hold">
+                            <p:stCondLst>
+                              <p:cond delay="0"/>
+                            </p:stCondLst>
+                            <p:childTnLst>
+                              <p:par>
+                                <p:cTn id="27" presetID="16" presetClass="entr" presetSubtype="21" fill="hold" grpId="0" nodeType="clickEffect">
+                                  <p:stCondLst>
+                                    <p:cond delay="0"/>
+                                  </p:stCondLst>
+                                  <p:childTnLst>
+                                    <p:set>
+                                      <p:cBhvr>
+                                        <p:cTn id="28" dur="1" fill="hold">
+                                          <p:stCondLst>
+                                            <p:cond delay="0"/>
+                                          </p:stCondLst>
+                                        </p:cTn>
+                                        <p:tgtEl>
+                                          <p:spTgt spid="9"/>
+                                        </p:tgtEl>
+                                        <p:attrNameLst>
+                                          <p:attrName>style.visibility</p:attrName>
+                                        </p:attrNameLst>
+                                      </p:cBhvr>
+                                      <p:to>
+                                        <p:strVal val="visible"/>
+                                      </p:to>
+                                    </p:set>
+                                    <p:animEffect transition="in" filter="barn(inVertical)">
+                                      <p:cBhvr>
+                                        <p:cTn id="29" dur="500"/>
+                                        <p:tgtEl>
+                                          <p:spTgt spid="9"/>
+                                        </p:tgtEl>
+                                      </p:cBhvr>
+                                    </p:animEffect>
+                                  </p:childTnLst>
+                                </p:cTn>
+                              </p:par>
+                              <p:par>
+                                <p:cTn id="30" presetID="16" presetClass="entr" presetSubtype="21" fill="hold" grpId="0" nodeType="withEffect">
+                                  <p:stCondLst>
+                                    <p:cond delay="0"/>
+                                  </p:stCondLst>
+                                  <p:childTnLst>
+                                    <p:set>
+                                      <p:cBhvr>
+                                        <p:cTn id="31" dur="1" fill="hold">
+                                          <p:stCondLst>
+                                            <p:cond delay="0"/>
+                                          </p:stCondLst>
+                                        </p:cTn>
+                                        <p:tgtEl>
+                                          <p:spTgt spid="10"/>
+                                        </p:tgtEl>
+                                        <p:attrNameLst>
+                                          <p:attrName>style.visibility</p:attrName>
+                                        </p:attrNameLst>
+                                      </p:cBhvr>
+                                      <p:to>
+                                        <p:strVal val="visible"/>
+                                      </p:to>
+                                    </p:set>
+                                    <p:animEffect transition="in" filter="barn(inVertical)">
+                                      <p:cBhvr>
+                                        <p:cTn id="32" dur="500"/>
+                                        <p:tgtEl>
+                                          <p:spTgt spid="10"/>
+                                        </p:tgtEl>
+                                      </p:cBhvr>
+                                    </p:animEffect>
+                                  </p:childTnLst>
+                                </p:cTn>
+                              </p:par>
+                              <p:par>
+                                <p:cTn id="33" presetID="16" presetClass="entr" presetSubtype="21" fill="hold" grpId="0" nodeType="withEffect">
+                                  <p:stCondLst>
+                                    <p:cond delay="0"/>
+                                  </p:stCondLst>
+                                  <p:childTnLst>
+                                    <p:set>
+                                      <p:cBhvr>
+                                        <p:cTn id="34" dur="1" fill="hold">
+                                          <p:stCondLst>
+                                            <p:cond delay="0"/>
+                                          </p:stCondLst>
+                                        </p:cTn>
+                                        <p:tgtEl>
+                                          <p:spTgt spid="11"/>
+                                        </p:tgtEl>
+                                        <p:attrNameLst>
+                                          <p:attrName>style.visibility</p:attrName>
+                                        </p:attrNameLst>
+                                      </p:cBhvr>
+                                      <p:to>
+                                        <p:strVal val="visible"/>
+                                      </p:to>
+                                    </p:set>
+                                    <p:animEffect transition="in" filter="barn(inVertical)">
+                                      <p:cBhvr>
+                                        <p:cTn id="35" dur="500"/>
+                                        <p:tgtEl>
+                                          <p:spTgt spid="11"/>
+                                        </p:tgtEl>
+                                      </p:cBhvr>
+                                    </p:animEffect>
+                                  </p:childTnLst>
+                                </p:cTn>
+                              </p:par>
+                            </p:childTnLst>
+                          </p:cTn>
+                        </p:par>
+                      </p:childTnLst>
+                    </p:cTn>
+                  </p:par>
+                  <p:par>
+                    <p:cTn id="36" fill="hold">
+                      <p:stCondLst>
+                        <p:cond delay="indefinite"/>
+                      </p:stCondLst>
+                      <p:childTnLst>
+                        <p:par>
+                          <p:cTn id="37" fill="hold">
+                            <p:stCondLst>
+                              <p:cond delay="0"/>
+                            </p:stCondLst>
+                            <p:childTnLst>
+                              <p:par>
+                                <p:cTn id="38" presetID="16" presetClass="entr" presetSubtype="21" fill="hold" grpId="0" nodeType="clickEffect">
+                                  <p:stCondLst>
+                                    <p:cond delay="0"/>
+                                  </p:stCondLst>
+                                  <p:childTnLst>
+                                    <p:set>
+                                      <p:cBhvr>
+                                        <p:cTn id="39" dur="1" fill="hold">
+                                          <p:stCondLst>
+                                            <p:cond delay="0"/>
+                                          </p:stCondLst>
+                                        </p:cTn>
+                                        <p:tgtEl>
+                                          <p:spTgt spid="12"/>
+                                        </p:tgtEl>
+                                        <p:attrNameLst>
+                                          <p:attrName>style.visibility</p:attrName>
+                                        </p:attrNameLst>
+                                      </p:cBhvr>
+                                      <p:to>
+                                        <p:strVal val="visible"/>
+                                      </p:to>
+                                    </p:set>
+                                    <p:animEffect transition="in" filter="barn(inVertical)">
+                                      <p:cBhvr>
+                                        <p:cTn id="40" dur="500"/>
+                                        <p:tgtEl>
+                                          <p:spTgt spid="12"/>
+                                        </p:tgtEl>
+                                      </p:cBhvr>
+                                    </p:animEffect>
+                                  </p:childTnLst>
+                                </p:cTn>
+                              </p:par>
+                              <p:par>
+                                <p:cTn id="41" presetID="16" presetClass="entr" presetSubtype="21" fill="hold" grpId="0" nodeType="withEffect">
+                                  <p:stCondLst>
+                                    <p:cond delay="0"/>
+                                  </p:stCondLst>
+                                  <p:childTnLst>
+                                    <p:set>
+                                      <p:cBhvr>
+                                        <p:cTn id="42" dur="1" fill="hold">
+                                          <p:stCondLst>
+                                            <p:cond delay="0"/>
+                                          </p:stCondLst>
+                                        </p:cTn>
+                                        <p:tgtEl>
+                                          <p:spTgt spid="13"/>
+                                        </p:tgtEl>
+                                        <p:attrNameLst>
+                                          <p:attrName>style.visibility</p:attrName>
+                                        </p:attrNameLst>
+                                      </p:cBhvr>
+                                      <p:to>
+                                        <p:strVal val="visible"/>
+                                      </p:to>
+                                    </p:set>
+                                    <p:animEffect transition="in" filter="barn(inVertical)">
+                                      <p:cBhvr>
+                                        <p:cTn id="43" dur="500"/>
+                                        <p:tgtEl>
+                                          <p:spTgt spid="13"/>
+                                        </p:tgtEl>
+                                      </p:cBhvr>
+                                    </p:animEffect>
+                                  </p:childTnLst>
+                                </p:cTn>
+                              </p:par>
+                              <p:par>
+                                <p:cTn id="44" presetID="16" presetClass="entr" presetSubtype="21" fill="hold" grpId="0" nodeType="withEffect">
+                                  <p:stCondLst>
+                                    <p:cond delay="0"/>
+                                  </p:stCondLst>
+                                  <p:childTnLst>
+                                    <p:set>
+                                      <p:cBhvr>
+                                        <p:cTn id="45" dur="1" fill="hold">
+                                          <p:stCondLst>
+                                            <p:cond delay="0"/>
+                                          </p:stCondLst>
+                                        </p:cTn>
+                                        <p:tgtEl>
+                                          <p:spTgt spid="14"/>
+                                        </p:tgtEl>
+                                        <p:attrNameLst>
+                                          <p:attrName>style.visibility</p:attrName>
+                                        </p:attrNameLst>
+                                      </p:cBhvr>
+                                      <p:to>
+                                        <p:strVal val="visible"/>
+                                      </p:to>
+                                    </p:set>
+                                    <p:animEffect transition="in" filter="barn(inVertical)">
+                                      <p:cBhvr>
+                                        <p:cTn id="46" dur="500"/>
+                                        <p:tgtEl>
+                                          <p:spTgt spid="14"/>
+                                        </p:tgtEl>
+                                      </p:cBhvr>
+                                    </p:animEffect>
+                                  </p:childTnLst>
+                                </p:cTn>
+                              </p:par>
+                            </p:childTnLst>
+                          </p:cTn>
+                        </p:par>
+                      </p:childTnLst>
+                    </p:cTn>
+                  </p:par>
+                  <p:par>
+                    <p:cTn id="47" fill="hold">
+                      <p:stCondLst>
+                        <p:cond delay="indefinite"/>
+                      </p:stCondLst>
+                      <p:childTnLst>
+                        <p:par>
+                          <p:cTn id="48" fill="hold">
+                            <p:stCondLst>
+                              <p:cond delay="0"/>
+                            </p:stCondLst>
+                            <p:childTnLst>
+                              <p:par>
+                                <p:cTn id="49" presetID="16" presetClass="entr" presetSubtype="21" fill="hold" grpId="0" nodeType="clickEffect">
+                                  <p:stCondLst>
+                                    <p:cond delay="0"/>
+                                  </p:stCondLst>
+                                  <p:childTnLst>
+                                    <p:set>
+                                      <p:cBhvr>
+                                        <p:cTn id="50" dur="1" fill="hold">
+                                          <p:stCondLst>
+                                            <p:cond delay="0"/>
+                                          </p:stCondLst>
+                                        </p:cTn>
+                                        <p:tgtEl>
+                                          <p:spTgt spid="15"/>
+                                        </p:tgtEl>
+                                        <p:attrNameLst>
+                                          <p:attrName>style.visibility</p:attrName>
+                                        </p:attrNameLst>
+                                      </p:cBhvr>
+                                      <p:to>
+                                        <p:strVal val="visible"/>
+                                      </p:to>
+                                    </p:set>
+                                    <p:animEffect transition="in" filter="barn(inVertical)">
+                                      <p:cBhvr>
+                                        <p:cTn id="51" dur="500"/>
+                                        <p:tgtEl>
+                                          <p:spTgt spid="15"/>
+                                        </p:tgtEl>
+                                      </p:cBhvr>
+                                    </p:animEffect>
+                                  </p:childTnLst>
+                                </p:cTn>
+                              </p:par>
+                              <p:par>
+                                <p:cTn id="52" presetID="16" presetClass="entr" presetSubtype="21" fill="hold" grpId="0" nodeType="withEffect">
+                                  <p:stCondLst>
+                                    <p:cond delay="0"/>
+                                  </p:stCondLst>
+                                  <p:childTnLst>
+                                    <p:set>
+                                      <p:cBhvr>
+                                        <p:cTn id="53" dur="1" fill="hold">
+                                          <p:stCondLst>
+                                            <p:cond delay="0"/>
+                                          </p:stCondLst>
+                                        </p:cTn>
+                                        <p:tgtEl>
+                                          <p:spTgt spid="16"/>
+                                        </p:tgtEl>
+                                        <p:attrNameLst>
+                                          <p:attrName>style.visibility</p:attrName>
+                                        </p:attrNameLst>
+                                      </p:cBhvr>
+                                      <p:to>
+                                        <p:strVal val="visible"/>
+                                      </p:to>
+                                    </p:set>
+                                    <p:animEffect transition="in" filter="barn(inVertical)">
+                                      <p:cBhvr>
+                                        <p:cTn id="54" dur="500"/>
+                                        <p:tgtEl>
+                                          <p:spTgt spid="16"/>
+                                        </p:tgtEl>
+                                      </p:cBhvr>
+                                    </p:animEffect>
+                                  </p:childTnLst>
+                                </p:cTn>
+                              </p:par>
+                              <p:par>
+                                <p:cTn id="55" presetID="16" presetClass="entr" presetSubtype="21" fill="hold" grpId="0" nodeType="withEffect">
+                                  <p:stCondLst>
+                                    <p:cond delay="0"/>
+                                  </p:stCondLst>
+                                  <p:childTnLst>
+                                    <p:set>
+                                      <p:cBhvr>
+                                        <p:cTn id="56" dur="1" fill="hold">
+                                          <p:stCondLst>
+                                            <p:cond delay="0"/>
+                                          </p:stCondLst>
+                                        </p:cTn>
+                                        <p:tgtEl>
+                                          <p:spTgt spid="17"/>
+                                        </p:tgtEl>
+                                        <p:attrNameLst>
+                                          <p:attrName>style.visibility</p:attrName>
+                                        </p:attrNameLst>
+                                      </p:cBhvr>
+                                      <p:to>
+                                        <p:strVal val="visible"/>
+                                      </p:to>
+                                    </p:set>
+                                    <p:animEffect transition="in" filter="barn(inVertical)">
+                                      <p:cBhvr>
+                                        <p:cTn id="57" dur="500"/>
+                                        <p:tgtEl>
+                                          <p:spTgt spid="17"/>
+                                        </p:tgtEl>
+                                      </p:cBhvr>
+                                    </p:animEffect>
+                                  </p:childTnLst>
+                                </p:cTn>
+                              </p:par>
+                            </p:childTnLst>
+                          </p:cTn>
+                        </p:par>
+                      </p:childTnLst>
+                    </p:cTn>
+                  </p:par>
+                  <p:par>
+                    <p:cTn id="58" fill="hold">
+                      <p:stCondLst>
+                        <p:cond delay="indefinite"/>
+                      </p:stCondLst>
+                      <p:childTnLst>
+                        <p:par>
+                          <p:cTn id="59" fill="hold">
+                            <p:stCondLst>
+                              <p:cond delay="0"/>
+                            </p:stCondLst>
+                            <p:childTnLst>
+                              <p:par>
+                                <p:cTn id="60" presetID="16" presetClass="entr" presetSubtype="21" fill="hold" grpId="0" nodeType="clickEffect">
+                                  <p:stCondLst>
+                                    <p:cond delay="0"/>
+                                  </p:stCondLst>
+                                  <p:childTnLst>
+                                    <p:set>
+                                      <p:cBhvr>
+                                        <p:cTn id="61" dur="1" fill="hold">
+                                          <p:stCondLst>
+                                            <p:cond delay="0"/>
+                                          </p:stCondLst>
+                                        </p:cTn>
+                                        <p:tgtEl>
+                                          <p:spTgt spid="18"/>
+                                        </p:tgtEl>
+                                        <p:attrNameLst>
+                                          <p:attrName>style.visibility</p:attrName>
+                                        </p:attrNameLst>
+                                      </p:cBhvr>
+                                      <p:to>
+                                        <p:strVal val="visible"/>
+                                      </p:to>
+                                    </p:set>
+                                    <p:animEffect transition="in" filter="barn(inVertical)">
+                                      <p:cBhvr>
+                                        <p:cTn id="62" dur="500"/>
+                                        <p:tgtEl>
+                                          <p:spTgt spid="18"/>
+                                        </p:tgtEl>
+                                      </p:cBhvr>
+                                    </p:animEffect>
+                                  </p:childTnLst>
+                                </p:cTn>
+                              </p:par>
+                              <p:par>
+                                <p:cTn id="63" presetID="16" presetClass="entr" presetSubtype="21" fill="hold" grpId="0" nodeType="withEffect">
+                                  <p:stCondLst>
+                                    <p:cond delay="0"/>
+                                  </p:stCondLst>
+                                  <p:childTnLst>
+                                    <p:set>
+                                      <p:cBhvr>
+                                        <p:cTn id="64" dur="1" fill="hold">
+                                          <p:stCondLst>
+                                            <p:cond delay="0"/>
+                                          </p:stCondLst>
+                                        </p:cTn>
+                                        <p:tgtEl>
+                                          <p:spTgt spid="19"/>
+                                        </p:tgtEl>
+                                        <p:attrNameLst>
+                                          <p:attrName>style.visibility</p:attrName>
+                                        </p:attrNameLst>
+                                      </p:cBhvr>
+                                      <p:to>
+                                        <p:strVal val="visible"/>
+                                      </p:to>
+                                    </p:set>
+                                    <p:animEffect transition="in" filter="barn(inVertical)">
+                                      <p:cBhvr>
+                                        <p:cTn id="65" dur="500"/>
+                                        <p:tgtEl>
+                                          <p:spTgt spid="19"/>
+                                        </p:tgtEl>
+                                      </p:cBhvr>
+                                    </p:animEffect>
+                                  </p:childTnLst>
+                                </p:cTn>
+                              </p:par>
+                              <p:par>
+                                <p:cTn id="66" presetID="16" presetClass="entr" presetSubtype="21" fill="hold" grpId="0" nodeType="withEffect">
+                                  <p:stCondLst>
+                                    <p:cond delay="0"/>
+                                  </p:stCondLst>
+                                  <p:childTnLst>
+                                    <p:set>
+                                      <p:cBhvr>
+                                        <p:cTn id="67" dur="1" fill="hold">
+                                          <p:stCondLst>
+                                            <p:cond delay="0"/>
+                                          </p:stCondLst>
+                                        </p:cTn>
+                                        <p:tgtEl>
+                                          <p:spTgt spid="20"/>
+                                        </p:tgtEl>
+                                        <p:attrNameLst>
+                                          <p:attrName>style.visibility</p:attrName>
+                                        </p:attrNameLst>
+                                      </p:cBhvr>
+                                      <p:to>
+                                        <p:strVal val="visible"/>
+                                      </p:to>
+                                    </p:set>
+                                    <p:animEffect transition="in" filter="barn(inVertical)">
+                                      <p:cBhvr>
+                                        <p:cTn id="68" dur="500"/>
+                                        <p:tgtEl>
+                                          <p:spTgt spid="20"/>
+                                        </p:tgtEl>
+                                      </p:cBhvr>
+                                    </p:animEffect>
+                                  </p:childTnLst>
+                                </p:cTn>
+                              </p:par>
+                            </p:childTnLst>
+                          </p:cTn>
+                        </p:par>
+                      </p:childTnLst>
+                    </p:cTn>
+                  </p:par>
+                  <p:par>
+                    <p:cTn id="69" fill="hold">
+                      <p:stCondLst>
+                        <p:cond delay="indefinite"/>
+                      </p:stCondLst>
+                      <p:childTnLst>
+                        <p:par>
+                          <p:cTn id="70" fill="hold">
+                            <p:stCondLst>
+                              <p:cond delay="0"/>
+                            </p:stCondLst>
+                            <p:childTnLst>
+                              <p:par>
+                                <p:cTn id="71" presetID="16" presetClass="entr" presetSubtype="21" fill="hold" grpId="0" nodeType="clickEffect">
+                                  <p:stCondLst>
+                                    <p:cond delay="0"/>
+                                  </p:stCondLst>
+                                  <p:childTnLst>
+                                    <p:set>
+                                      <p:cBhvr>
+                                        <p:cTn id="72" dur="1" fill="hold">
+                                          <p:stCondLst>
+                                            <p:cond delay="0"/>
+                                          </p:stCondLst>
+                                        </p:cTn>
+                                        <p:tgtEl>
+                                          <p:spTgt spid="21"/>
+                                        </p:tgtEl>
+                                        <p:attrNameLst>
+                                          <p:attrName>style.visibility</p:attrName>
+                                        </p:attrNameLst>
+                                      </p:cBhvr>
+                                      <p:to>
+                                        <p:strVal val="visible"/>
+                                      </p:to>
+                                    </p:set>
+                                    <p:animEffect transition="in" filter="barn(inVertical)">
+                                      <p:cBhvr>
+                                        <p:cTn id="73" dur="500"/>
+                                        <p:tgtEl>
+                                          <p:spTgt spid="21"/>
+                                        </p:tgtEl>
+                                      </p:cBhvr>
+                                    </p:animEffect>
+                                  </p:childTnLst>
+                                </p:cTn>
+                              </p:par>
+                              <p:par>
+                                <p:cTn id="74" presetID="16" presetClass="entr" presetSubtype="21" fill="hold" grpId="0" nodeType="withEffect">
+                                  <p:stCondLst>
+                                    <p:cond delay="0"/>
+                                  </p:stCondLst>
+                                  <p:childTnLst>
+                                    <p:set>
+                                      <p:cBhvr>
+                                        <p:cTn id="75" dur="1" fill="hold">
+                                          <p:stCondLst>
+                                            <p:cond delay="0"/>
+                                          </p:stCondLst>
+                                        </p:cTn>
+                                        <p:tgtEl>
+                                          <p:spTgt spid="22"/>
+                                        </p:tgtEl>
+                                        <p:attrNameLst>
+                                          <p:attrName>style.visibility</p:attrName>
+                                        </p:attrNameLst>
+                                      </p:cBhvr>
+                                      <p:to>
+                                        <p:strVal val="visible"/>
+                                      </p:to>
+                                    </p:set>
+                                    <p:animEffect transition="in" filter="barn(inVertical)">
+                                      <p:cBhvr>
+                                        <p:cTn id="76" dur="500"/>
+                                        <p:tgtEl>
+                                          <p:spTgt spid="22"/>
+                                        </p:tgtEl>
+                                      </p:cBhvr>
+                                    </p:animEffect>
+                                  </p:childTnLst>
+                                </p:cTn>
+                              </p:par>
+                              <p:par>
+                                <p:cTn id="77" presetID="16" presetClass="entr" presetSubtype="21" fill="hold" grpId="0" nodeType="withEffect">
+                                  <p:stCondLst>
+                                    <p:cond delay="0"/>
+                                  </p:stCondLst>
+                                  <p:childTnLst>
+                                    <p:set>
+                                      <p:cBhvr>
+                                        <p:cTn id="78" dur="1" fill="hold">
+                                          <p:stCondLst>
+                                            <p:cond delay="0"/>
+                                          </p:stCondLst>
+                                        </p:cTn>
+                                        <p:tgtEl>
+                                          <p:spTgt spid="23"/>
+                                        </p:tgtEl>
+                                        <p:attrNameLst>
+                                          <p:attrName>style.visibility</p:attrName>
+                                        </p:attrNameLst>
+                                      </p:cBhvr>
+                                      <p:to>
+                                        <p:strVal val="visible"/>
+                                      </p:to>
+                                    </p:set>
+                                    <p:animEffect transition="in" filter="barn(inVertical)">
+                                      <p:cBhvr>
+                                        <p:cTn id="79" dur="500"/>
+                                        <p:tgtEl>
+                                          <p:spTgt spid="23"/>
+                                        </p:tgtEl>
+                                      </p:cBhvr>
+                                    </p:animEffect>
+                                  </p:childTnLst>
+                                </p:cTn>
+                              </p:par>
+                            </p:childTnLst>
+                          </p:cTn>
+                        </p:par>
+                      </p:childTnLst>
+                    </p:cTn>
+                  </p:par>
+                  <p:par>
+                    <p:cTn id="80" fill="hold">
+                      <p:stCondLst>
+                        <p:cond delay="indefinite"/>
+                      </p:stCondLst>
+                      <p:childTnLst>
+                        <p:par>
+                          <p:cTn id="81" fill="hold">
+                            <p:stCondLst>
+                              <p:cond delay="0"/>
+                            </p:stCondLst>
+                            <p:childTnLst>
+                              <p:par>
+                                <p:cTn id="82" presetID="16" presetClass="entr" presetSubtype="21" fill="hold" grpId="0" nodeType="clickEffect">
+                                  <p:stCondLst>
+                                    <p:cond delay="0"/>
+                                  </p:stCondLst>
+                                  <p:childTnLst>
+                                    <p:set>
+                                      <p:cBhvr>
+                                        <p:cTn id="83" dur="1" fill="hold">
+                                          <p:stCondLst>
+                                            <p:cond delay="0"/>
+                                          </p:stCondLst>
+                                        </p:cTn>
+                                        <p:tgtEl>
+                                          <p:spTgt spid="24"/>
+                                        </p:tgtEl>
+                                        <p:attrNameLst>
+                                          <p:attrName>style.visibility</p:attrName>
+                                        </p:attrNameLst>
+                                      </p:cBhvr>
+                                      <p:to>
+                                        <p:strVal val="visible"/>
+                                      </p:to>
+                                    </p:set>
+                                    <p:animEffect transition="in" filter="barn(inVertical)">
+                                      <p:cBhvr>
+                                        <p:cTn id="84" dur="500"/>
+                                        <p:tgtEl>
+                                          <p:spTgt spid="24"/>
+                                        </p:tgtEl>
+                                      </p:cBhvr>
+                                    </p:animEffect>
+                                  </p:childTnLst>
+                                </p:cTn>
+                              </p:par>
+                              <p:par>
+                                <p:cTn id="85" presetID="16" presetClass="entr" presetSubtype="21" fill="hold" grpId="0" nodeType="withEffect">
+                                  <p:stCondLst>
+                                    <p:cond delay="0"/>
+                                  </p:stCondLst>
+                                  <p:childTnLst>
+                                    <p:set>
+                                      <p:cBhvr>
+                                        <p:cTn id="86" dur="1" fill="hold">
+                                          <p:stCondLst>
+                                            <p:cond delay="0"/>
+                                          </p:stCondLst>
+                                        </p:cTn>
+                                        <p:tgtEl>
+                                          <p:spTgt spid="25"/>
+                                        </p:tgtEl>
+                                        <p:attrNameLst>
+                                          <p:attrName>style.visibility</p:attrName>
+                                        </p:attrNameLst>
+                                      </p:cBhvr>
+                                      <p:to>
+                                        <p:strVal val="visible"/>
+                                      </p:to>
+                                    </p:set>
+                                    <p:animEffect transition="in" filter="barn(inVertical)">
+                                      <p:cBhvr>
+                                        <p:cTn id="87" dur="500"/>
+                                        <p:tgtEl>
+                                          <p:spTgt spid="25"/>
+                                        </p:tgtEl>
+                                      </p:cBhvr>
+                                    </p:animEffect>
+                                  </p:childTnLst>
+                                </p:cTn>
+                              </p:par>
+                              <p:par>
+                                <p:cTn id="88" presetID="16" presetClass="entr" presetSubtype="21" fill="hold" grpId="0" nodeType="withEffect">
+                                  <p:stCondLst>
+                                    <p:cond delay="0"/>
+                                  </p:stCondLst>
+                                  <p:childTnLst>
+                                    <p:set>
+                                      <p:cBhvr>
+                                        <p:cTn id="89" dur="1" fill="hold">
+                                          <p:stCondLst>
+                                            <p:cond delay="0"/>
+                                          </p:stCondLst>
+                                        </p:cTn>
+                                        <p:tgtEl>
+                                          <p:spTgt spid="26"/>
+                                        </p:tgtEl>
+                                        <p:attrNameLst>
+                                          <p:attrName>style.visibility</p:attrName>
+                                        </p:attrNameLst>
+                                      </p:cBhvr>
+                                      <p:to>
+                                        <p:strVal val="visible"/>
+                                      </p:to>
+                                    </p:set>
+                                    <p:animEffect transition="in" filter="barn(inVertical)">
+                                      <p:cBhvr>
+                                        <p:cTn id="90" dur="500"/>
+                                        <p:tgtEl>
+                                          <p:spTgt spid="26"/>
+                                        </p:tgtEl>
+                                      </p:cBhvr>
+                                    </p:animEffect>
+                                  </p:childTnLst>
+                                </p:cTn>
+                              </p:par>
+                            </p:childTnLst>
+                          </p:cTn>
+                        </p:par>
+                      </p:childTnLst>
+                    </p:cTn>
+                  </p:par>
+                  <p:par>
+                    <p:cTn id="91" fill="hold">
+                      <p:stCondLst>
+                        <p:cond delay="indefinite"/>
+                      </p:stCondLst>
+                      <p:childTnLst>
+                        <p:par>
+                          <p:cTn id="92" fill="hold">
+                            <p:stCondLst>
+                              <p:cond delay="0"/>
+                            </p:stCondLst>
+                            <p:childTnLst>
+                              <p:par>
+                                <p:cTn id="93" presetID="16" presetClass="entr" presetSubtype="21" fill="hold" grpId="0" nodeType="clickEffect">
+                                  <p:stCondLst>
+                                    <p:cond delay="0"/>
+                                  </p:stCondLst>
+                                  <p:childTnLst>
+                                    <p:set>
+                                      <p:cBhvr>
+                                        <p:cTn id="94" dur="1" fill="hold">
+                                          <p:stCondLst>
+                                            <p:cond delay="0"/>
+                                          </p:stCondLst>
+                                        </p:cTn>
+                                        <p:tgtEl>
+                                          <p:spTgt spid="27"/>
+                                        </p:tgtEl>
+                                        <p:attrNameLst>
+                                          <p:attrName>style.visibility</p:attrName>
+                                        </p:attrNameLst>
+                                      </p:cBhvr>
+                                      <p:to>
+                                        <p:strVal val="visible"/>
+                                      </p:to>
+                                    </p:set>
+                                    <p:animEffect transition="in" filter="barn(inVertical)">
+                                      <p:cBhvr>
+                                        <p:cTn id="95" dur="500"/>
+                                        <p:tgtEl>
+                                          <p:spTgt spid="27"/>
+                                        </p:tgtEl>
+                                      </p:cBhvr>
+                                    </p:animEffect>
+                                  </p:childTnLst>
+                                </p:cTn>
+                              </p:par>
+                              <p:par>
+                                <p:cTn id="96" presetID="16" presetClass="entr" presetSubtype="21" fill="hold" grpId="0" nodeType="withEffect">
+                                  <p:stCondLst>
+                                    <p:cond delay="0"/>
+                                  </p:stCondLst>
+                                  <p:childTnLst>
+                                    <p:set>
+                                      <p:cBhvr>
+                                        <p:cTn id="97" dur="1" fill="hold">
+                                          <p:stCondLst>
+                                            <p:cond delay="0"/>
+                                          </p:stCondLst>
+                                        </p:cTn>
+                                        <p:tgtEl>
+                                          <p:spTgt spid="28"/>
+                                        </p:tgtEl>
+                                        <p:attrNameLst>
+                                          <p:attrName>style.visibility</p:attrName>
+                                        </p:attrNameLst>
+                                      </p:cBhvr>
+                                      <p:to>
+                                        <p:strVal val="visible"/>
+                                      </p:to>
+                                    </p:set>
+                                    <p:animEffect transition="in" filter="barn(inVertical)">
+                                      <p:cBhvr>
+                                        <p:cTn id="98" dur="500"/>
+                                        <p:tgtEl>
+                                          <p:spTgt spid="28"/>
+                                        </p:tgtEl>
+                                      </p:cBhvr>
+                                    </p:animEffect>
+                                  </p:childTnLst>
+                                </p:cTn>
+                              </p:par>
+                              <p:par>
+                                <p:cTn id="99" presetID="16" presetClass="entr" presetSubtype="21" fill="hold" grpId="0" nodeType="withEffect">
+                                  <p:stCondLst>
+                                    <p:cond delay="0"/>
+                                  </p:stCondLst>
+                                  <p:childTnLst>
+                                    <p:set>
+                                      <p:cBhvr>
+                                        <p:cTn id="100" dur="1" fill="hold">
+                                          <p:stCondLst>
+                                            <p:cond delay="0"/>
+                                          </p:stCondLst>
+                                        </p:cTn>
+                                        <p:tgtEl>
+                                          <p:spTgt spid="29"/>
+                                        </p:tgtEl>
+                                        <p:attrNameLst>
+                                          <p:attrName>style.visibility</p:attrName>
+                                        </p:attrNameLst>
+                                      </p:cBhvr>
+                                      <p:to>
+                                        <p:strVal val="visible"/>
+                                      </p:to>
+                                    </p:set>
+                                    <p:animEffect transition="in" filter="barn(inVertical)">
+                                      <p:cBhvr>
+                                        <p:cTn id="101" dur="500"/>
+                                        <p:tgtEl>
+                                          <p:spTgt spid="29"/>
+                                        </p:tgtEl>
+                                      </p:cBhvr>
+                                    </p:animEffect>
+                                  </p:childTnLst>
+                                </p:cTn>
+                              </p:par>
+                            </p:childTnLst>
+                          </p:cTn>
+                        </p:par>
+                      </p:childTnLst>
+                    </p:cTn>
+                  </p:par>
+                  <p:par>
+                    <p:cTn id="102" fill="hold">
+                      <p:stCondLst>
+                        <p:cond delay="indefinite"/>
+                      </p:stCondLst>
+                      <p:childTnLst>
+                        <p:par>
+                          <p:cTn id="103" fill="hold">
+                            <p:stCondLst>
+                              <p:cond delay="0"/>
+                            </p:stCondLst>
+                            <p:childTnLst>
+                              <p:par>
+                                <p:cTn id="104" presetID="16" presetClass="entr" presetSubtype="21" fill="hold" grpId="0" nodeType="clickEffect">
+                                  <p:stCondLst>
+                                    <p:cond delay="0"/>
+                                  </p:stCondLst>
+                                  <p:childTnLst>
+                                    <p:set>
+                                      <p:cBhvr>
+                                        <p:cTn id="105" dur="1" fill="hold">
+                                          <p:stCondLst>
+                                            <p:cond delay="0"/>
+                                          </p:stCondLst>
+                                        </p:cTn>
+                                        <p:tgtEl>
+                                          <p:spTgt spid="31"/>
+                                        </p:tgtEl>
+                                        <p:attrNameLst>
+                                          <p:attrName>style.visibility</p:attrName>
+                                        </p:attrNameLst>
+                                      </p:cBhvr>
+                                      <p:to>
+                                        <p:strVal val="visible"/>
+                                      </p:to>
+                                    </p:set>
+                                    <p:animEffect transition="in" filter="barn(inVertical)">
+                                      <p:cBhvr>
+                                        <p:cTn id="106" dur="500"/>
+                                        <p:tgtEl>
+                                          <p:spTgt spid="31"/>
+                                        </p:tgtEl>
+                                      </p:cBhvr>
+                                    </p:animEffect>
+                                  </p:childTnLst>
+                                </p:cTn>
+                              </p:par>
+                              <p:par>
+                                <p:cTn id="107" presetID="16" presetClass="entr" presetSubtype="21" fill="hold" grpId="0" nodeType="withEffect">
+                                  <p:stCondLst>
+                                    <p:cond delay="0"/>
+                                  </p:stCondLst>
+                                  <p:childTnLst>
+                                    <p:set>
+                                      <p:cBhvr>
+                                        <p:cTn id="108" dur="1" fill="hold">
+                                          <p:stCondLst>
+                                            <p:cond delay="0"/>
+                                          </p:stCondLst>
+                                        </p:cTn>
+                                        <p:tgtEl>
+                                          <p:spTgt spid="30"/>
+                                        </p:tgtEl>
+                                        <p:attrNameLst>
+                                          <p:attrName>style.visibility</p:attrName>
+                                        </p:attrNameLst>
+                                      </p:cBhvr>
+                                      <p:to>
+                                        <p:strVal val="visible"/>
+                                      </p:to>
+                                    </p:set>
+                                    <p:animEffect transition="in" filter="barn(inVertical)">
+                                      <p:cBhvr>
+                                        <p:cTn id="109" dur="500"/>
+                                        <p:tgtEl>
+                                          <p:spTgt spid="30"/>
+                                        </p:tgtEl>
+                                      </p:cBhvr>
+                                    </p:animEffect>
+                                  </p:childTnLst>
+                                </p:cTn>
+                              </p:par>
+                              <p:par>
+                                <p:cTn id="110" presetID="16" presetClass="entr" presetSubtype="21" fill="hold" grpId="0" nodeType="withEffect">
+                                  <p:stCondLst>
+                                    <p:cond delay="0"/>
+                                  </p:stCondLst>
+                                  <p:childTnLst>
+                                    <p:set>
+                                      <p:cBhvr>
+                                        <p:cTn id="111" dur="1" fill="hold">
+                                          <p:stCondLst>
+                                            <p:cond delay="0"/>
+                                          </p:stCondLst>
+                                        </p:cTn>
+                                        <p:tgtEl>
+                                          <p:spTgt spid="32"/>
+                                        </p:tgtEl>
+                                        <p:attrNameLst>
+                                          <p:attrName>style.visibility</p:attrName>
+                                        </p:attrNameLst>
+                                      </p:cBhvr>
+                                      <p:to>
+                                        <p:strVal val="visible"/>
+                                      </p:to>
+                                    </p:set>
+                                    <p:animEffect transition="in" filter="barn(inVertical)">
+                                      <p:cBhvr>
+                                        <p:cTn id="112" dur="500"/>
+                                        <p:tgtEl>
+                                          <p:spTgt spid="32"/>
+                                        </p:tgtEl>
+                                      </p:cBhvr>
+                                    </p:animEffect>
+                                  </p:childTnLst>
+                                </p:cTn>
+                              </p:par>
+                            </p:childTnLst>
+                          </p:cTn>
+                        </p:par>
+                      </p:childTnLst>
+                    </p:cTn>
+                  </p:par>
+                  <p:par>
+                    <p:cTn id="113" fill="hold">
+                      <p:stCondLst>
+                        <p:cond delay="indefinite"/>
+                      </p:stCondLst>
+                      <p:childTnLst>
+                        <p:par>
+                          <p:cTn id="114" fill="hold">
+                            <p:stCondLst>
+                              <p:cond delay="0"/>
+                            </p:stCondLst>
+                            <p:childTnLst>
+                              <p:par>
+                                <p:cTn id="115" presetID="16" presetClass="entr" presetSubtype="21" fill="hold" grpId="0" nodeType="clickEffect">
+                                  <p:stCondLst>
+                                    <p:cond delay="0"/>
+                                  </p:stCondLst>
+                                  <p:childTnLst>
+                                    <p:set>
+                                      <p:cBhvr>
+                                        <p:cTn id="116" dur="1" fill="hold">
+                                          <p:stCondLst>
+                                            <p:cond delay="0"/>
+                                          </p:stCondLst>
+                                        </p:cTn>
+                                        <p:tgtEl>
+                                          <p:spTgt spid="33"/>
+                                        </p:tgtEl>
+                                        <p:attrNameLst>
+                                          <p:attrName>style.visibility</p:attrName>
+                                        </p:attrNameLst>
+                                      </p:cBhvr>
+                                      <p:to>
+                                        <p:strVal val="visible"/>
+                                      </p:to>
+                                    </p:set>
+                                    <p:animEffect transition="in" filter="barn(inVertical)">
+                                      <p:cBhvr>
+                                        <p:cTn id="117" dur="500"/>
+                                        <p:tgtEl>
+                                          <p:spTgt spid="33"/>
+                                        </p:tgtEl>
+                                      </p:cBhvr>
+                                    </p:animEffect>
+                                  </p:childTnLst>
+                                </p:cTn>
+                              </p:par>
+                              <p:par>
+                                <p:cTn id="118" presetID="16" presetClass="entr" presetSubtype="21" fill="hold" grpId="0" nodeType="withEffect">
+                                  <p:stCondLst>
+                                    <p:cond delay="0"/>
+                                  </p:stCondLst>
+                                  <p:childTnLst>
+                                    <p:set>
+                                      <p:cBhvr>
+                                        <p:cTn id="119" dur="1" fill="hold">
+                                          <p:stCondLst>
+                                            <p:cond delay="0"/>
+                                          </p:stCondLst>
+                                        </p:cTn>
+                                        <p:tgtEl>
+                                          <p:spTgt spid="34"/>
+                                        </p:tgtEl>
+                                        <p:attrNameLst>
+                                          <p:attrName>style.visibility</p:attrName>
+                                        </p:attrNameLst>
+                                      </p:cBhvr>
+                                      <p:to>
+                                        <p:strVal val="visible"/>
+                                      </p:to>
+                                    </p:set>
+                                    <p:animEffect transition="in" filter="barn(inVertical)">
+                                      <p:cBhvr>
+                                        <p:cTn id="120" dur="500"/>
+                                        <p:tgtEl>
+                                          <p:spTgt spid="34"/>
+                                        </p:tgtEl>
+                                      </p:cBhvr>
+                                    </p:animEffect>
+                                  </p:childTnLst>
+                                </p:cTn>
+                              </p:par>
+                              <p:par>
+                                <p:cTn id="121" presetID="16" presetClass="entr" presetSubtype="21" fill="hold" grpId="0" nodeType="withEffect">
+                                  <p:stCondLst>
+                                    <p:cond delay="0"/>
+                                  </p:stCondLst>
+                                  <p:childTnLst>
+                                    <p:set>
+                                      <p:cBhvr>
+                                        <p:cTn id="122" dur="1" fill="hold">
+                                          <p:stCondLst>
+                                            <p:cond delay="0"/>
+                                          </p:stCondLst>
+                                        </p:cTn>
+                                        <p:tgtEl>
+                                          <p:spTgt spid="35"/>
+                                        </p:tgtEl>
+                                        <p:attrNameLst>
+                                          <p:attrName>style.visibility</p:attrName>
+                                        </p:attrNameLst>
+                                      </p:cBhvr>
+                                      <p:to>
+                                        <p:strVal val="visible"/>
+                                      </p:to>
+                                    </p:set>
+                                    <p:animEffect transition="in" filter="barn(inVertical)">
+                                      <p:cBhvr>
+                                        <p:cTn id="123" dur="500"/>
+                                        <p:tgtEl>
+                                          <p:spTgt spid="35"/>
+                                        </p:tgtEl>
+                                      </p:cBhvr>
+                                    </p:animEffect>
+                                  </p:childTnLst>
+                                </p:cTn>
+                              </p:par>
+                            </p:childTnLst>
+                          </p:cTn>
+                        </p:par>
+                      </p:childTnLst>
+                    </p:cTn>
+                  </p:par>
+                  <p:par>
+                    <p:cTn id="124" fill="hold">
+                      <p:stCondLst>
+                        <p:cond delay="indefinite"/>
+                      </p:stCondLst>
+                      <p:childTnLst>
+                        <p:par>
+                          <p:cTn id="125" fill="hold">
+                            <p:stCondLst>
+                              <p:cond delay="0"/>
+                            </p:stCondLst>
+                            <p:childTnLst>
+                              <p:par>
+                                <p:cTn id="126" presetID="16" presetClass="entr" presetSubtype="21" fill="hold" grpId="0" nodeType="clickEffect">
+                                  <p:stCondLst>
+                                    <p:cond delay="0"/>
+                                  </p:stCondLst>
+                                  <p:childTnLst>
+                                    <p:set>
+                                      <p:cBhvr>
+                                        <p:cTn id="127" dur="1" fill="hold">
+                                          <p:stCondLst>
+                                            <p:cond delay="0"/>
+                                          </p:stCondLst>
+                                        </p:cTn>
+                                        <p:tgtEl>
+                                          <p:spTgt spid="36"/>
+                                        </p:tgtEl>
+                                        <p:attrNameLst>
+                                          <p:attrName>style.visibility</p:attrName>
+                                        </p:attrNameLst>
+                                      </p:cBhvr>
+                                      <p:to>
+                                        <p:strVal val="visible"/>
+                                      </p:to>
+                                    </p:set>
+                                    <p:animEffect transition="in" filter="barn(inVertical)">
+                                      <p:cBhvr>
+                                        <p:cTn id="128" dur="500"/>
+                                        <p:tgtEl>
+                                          <p:spTgt spid="36"/>
+                                        </p:tgtEl>
+                                      </p:cBhvr>
+                                    </p:animEffect>
+                                  </p:childTnLst>
+                                </p:cTn>
+                              </p:par>
+                              <p:par>
+                                <p:cTn id="129" presetID="16" presetClass="entr" presetSubtype="21" fill="hold" grpId="0" nodeType="withEffect">
+                                  <p:stCondLst>
+                                    <p:cond delay="0"/>
+                                  </p:stCondLst>
+                                  <p:childTnLst>
+                                    <p:set>
+                                      <p:cBhvr>
+                                        <p:cTn id="130" dur="1" fill="hold">
+                                          <p:stCondLst>
+                                            <p:cond delay="0"/>
+                                          </p:stCondLst>
+                                        </p:cTn>
+                                        <p:tgtEl>
+                                          <p:spTgt spid="37"/>
+                                        </p:tgtEl>
+                                        <p:attrNameLst>
+                                          <p:attrName>style.visibility</p:attrName>
+                                        </p:attrNameLst>
+                                      </p:cBhvr>
+                                      <p:to>
+                                        <p:strVal val="visible"/>
+                                      </p:to>
+                                    </p:set>
+                                    <p:animEffect transition="in" filter="barn(inVertical)">
+                                      <p:cBhvr>
+                                        <p:cTn id="131" dur="500"/>
+                                        <p:tgtEl>
+                                          <p:spTgt spid="37"/>
+                                        </p:tgtEl>
+                                      </p:cBhvr>
+                                    </p:animEffect>
+                                  </p:childTnLst>
+                                </p:cTn>
+                              </p:par>
+                              <p:par>
+                                <p:cTn id="132" presetID="16" presetClass="entr" presetSubtype="21" fill="hold" grpId="0" nodeType="withEffect">
+                                  <p:stCondLst>
+                                    <p:cond delay="0"/>
+                                  </p:stCondLst>
+                                  <p:childTnLst>
+                                    <p:set>
+                                      <p:cBhvr>
+                                        <p:cTn id="133" dur="1" fill="hold">
+                                          <p:stCondLst>
+                                            <p:cond delay="0"/>
+                                          </p:stCondLst>
+                                        </p:cTn>
+                                        <p:tgtEl>
+                                          <p:spTgt spid="38"/>
+                                        </p:tgtEl>
+                                        <p:attrNameLst>
+                                          <p:attrName>style.visibility</p:attrName>
+                                        </p:attrNameLst>
+                                      </p:cBhvr>
+                                      <p:to>
+                                        <p:strVal val="visible"/>
+                                      </p:to>
+                                    </p:set>
+                                    <p:animEffect transition="in" filter="barn(inVertical)">
+                                      <p:cBhvr>
+                                        <p:cTn id="134" dur="500"/>
+                                        <p:tgtEl>
+                                          <p:spTgt spid="38"/>
+                                        </p:tgtEl>
+                                      </p:cBhvr>
+                                    </p:animEffect>
+                                  </p:childTnLst>
+                                </p:cTn>
+                              </p:par>
+                            </p:childTnLst>
+                          </p:cTn>
+                        </p:par>
+                      </p:childTnLst>
+                    </p:cTn>
+                  </p:par>
+                </p:childTnLst>
+              </p:cTn>
+              <p:prevCondLst>
+                <p:cond evt="onPrev" delay="0">
+                  <p:tgtEl>
+                    <p:sldTgt/>
+                  </p:tgtEl>
+                </p:cond>
+              </p:prevCondLst>
+              <p:nextCondLst>
+                <p:cond evt="onNext" delay="0">
+                  <p:tgtEl>
+                    <p:sldTgt/>
+                  </p:tgtEl>
+                </p:cond>
+              </p:nextCondLst>
+            </p:seq>
+          </p:childTnLst>
+        </p:cTn>
+      </p:par>
+    </p:tnLst>
+    <p:bldLst>
+      <p:bldP spid="3" grpId="0" animBg="1"/>
+      <p:bldP spid="4" grpId="0" animBg="1"/>
+      <p:bldP spid="5" grpId="0" animBg="1"/>
+      <p:bldP spid="6" grpId="0" animBg="1"/>
+      <p:bldP spid="7" grpId="0" animBg="1"/>
+      <p:bldP spid="8" grpId="0" animBg="1"/>
+      <p:bldP spid="9" grpId="0" animBg="1"/>
+      <p:bldP spid="10" grpId="0" animBg="1"/>
+      <p:bldP spid="11" grpId="0" animBg="1"/>
+      <p:bldP spid="12" grpId="0" animBg="1"/>
+      <p:bldP spid="13" grpId="0" animBg="1"/>
+      <p:bldP spid="14" grpId="0" animBg="1"/>
+      <p:bldP spid="15" grpId="0" animBg="1"/>
+      <p:bldP spid="16" grpId="0" animBg="1"/>
+      <p:bldP spid="17" grpId="0" animBg="1"/>
+      <p:bldP spid="18" grpId="0" animBg="1"/>
+      <p:bldP spid="19" grpId="0" animBg="1"/>
+      <p:bldP spid="20" grpId="0" animBg="1"/>
+      <p:bldP spid="21" grpId="0" animBg="1"/>
+      <p:bldP spid="22" grpId="0" animBg="1"/>
+      <p:bldP spid="23" grpId="0" animBg="1"/>
+      <p:bldP spid="24" grpId="0" animBg="1"/>
+      <p:bldP spid="25" grpId="0" animBg="1"/>
+      <p:bldP spid="26" grpId="0" animBg="1"/>
+      <p:bldP spid="27" grpId="0" animBg="1"/>
+      <p:bldP spid="28" grpId="0" animBg="1"/>
+      <p:bldP spid="29" grpId="0" animBg="1"/>
+      <p:bldP spid="30" grpId="0" animBg="1"/>
+      <p:bldP spid="31" grpId="0" animBg="1"/>
+      <p:bldP spid="32" grpId="0" animBg="1"/>
+      <p:bldP spid="33" grpId="0" animBg="1"/>
+      <p:bldP spid="34" grpId="0" animBg="1"/>
+      <p:bldP spid="35" grpId="0" animBg="1"/>
+      <p:bldP spid="36" grpId="0" animBg="1"/>
+      <p:bldP spid="37" grpId="0" animBg="1"/>
+      <p:bldP spid="38" grpId="0" animBg="1"/>
+    </p:bldLst>
+  </p:timing>
 </p:sld>
 </file>
 

</xml_diff>